<commit_message>
Add dedicated SentryOps input and output slides
</commit_message>
<xml_diff>
--- a/docs/presentation/SentryOps_Master_Presentation.pptx
+++ b/docs/presentation/SentryOps_Master_Presentation.pptx
@@ -10,6 +10,8 @@
     <p:sldId id="258" r:id="rId9"/>
     <p:sldId id="259" r:id="rId10"/>
     <p:sldId id="260" r:id="rId11"/>
+    <p:sldId id="267" r:id="rId18"/>
+    <p:sldId id="268" r:id="rId19"/>
     <p:sldId id="261" r:id="rId12"/>
     <p:sldId id="262" r:id="rId13"/>
     <p:sldId id="263" r:id="rId14"/>
@@ -4913,6 +4915,2000 @@
 </p:sld>
 </file>
 
+<file path=ppt/slides/slide12.xml><?xml version="1.0" encoding="utf-8"?>
+<p:sld xmlns:a="http://schemas.openxmlformats.org/drawingml/2006/main" xmlns:p="http://schemas.openxmlformats.org/presentationml/2006/main" xmlns:r="http://schemas.openxmlformats.org/officeDocument/2006/relationships">
+  <p:cSld>
+    <p:spTree>
+      <p:nvGrpSpPr>
+        <p:cNvPr id="1" name=""/>
+        <p:cNvGrpSpPr/>
+        <p:nvPr/>
+      </p:nvGrpSpPr>
+      <p:grpSpPr/>
+      <p:sp>
+        <p:nvSpPr>
+          <p:cNvPr id="2" name="Rectangle 1"/>
+          <p:cNvSpPr/>
+          <p:nvPr/>
+        </p:nvSpPr>
+        <p:spPr>
+          <a:xfrm>
+            <a:off x="0" y="0"/>
+            <a:ext cx="12191695" cy="6858000"/>
+          </a:xfrm>
+          <a:prstGeom prst="rect">
+            <a:avLst/>
+          </a:prstGeom>
+          <a:solidFill>
+            <a:srgbClr val="0F172A"/>
+          </a:solidFill>
+          <a:ln>
+            <a:solidFill>
+              <a:srgbClr val="0F172A"/>
+            </a:solidFill>
+          </a:ln>
+        </p:spPr>
+        <p:style>
+          <a:lnRef idx="1">
+            <a:schemeClr val="accent1"/>
+          </a:lnRef>
+          <a:fillRef idx="3">
+            <a:schemeClr val="accent1"/>
+          </a:fillRef>
+          <a:effectRef idx="2">
+            <a:schemeClr val="accent1"/>
+          </a:effectRef>
+          <a:fontRef idx="minor">
+            <a:schemeClr val="lt1"/>
+          </a:fontRef>
+        </p:style>
+        <p:txBody>
+          <a:bodyPr rtlCol="0" anchor="ctr"/>
+          <a:lstStyle/>
+          <a:p>
+            <a:pPr algn="ctr"/>
+          </a:p>
+        </p:txBody>
+      </p:sp>
+      <p:sp>
+        <p:nvSpPr>
+          <p:cNvPr id="3" name="TextBox 2"/>
+          <p:cNvSpPr txBox="1"/>
+          <p:nvPr/>
+        </p:nvSpPr>
+        <p:spPr>
+          <a:xfrm>
+            <a:off x="731520" y="365760"/>
+            <a:ext cx="10728655" cy="868680"/>
+          </a:xfrm>
+          <a:prstGeom prst="rect">
+            <a:avLst/>
+          </a:prstGeom>
+          <a:noFill/>
+        </p:spPr>
+        <p:txBody>
+          <a:bodyPr wrap="square" lIns="0" rIns="0" tIns="0" bIns="0">
+            <a:spAutoFit/>
+          </a:bodyPr>
+          <a:lstStyle/>
+          <a:p>
+            <a:pPr>
+              <a:spcAft>
+                <a:spcPts val="300"/>
+              </a:spcAft>
+              <a:defRPr sz="2400" b="1">
+                <a:solidFill>
+                  <a:srgbClr val="FFFFFF"/>
+                </a:solidFill>
+                <a:latin typeface="Segoe UI"/>
+              </a:defRPr>
+            </a:pPr>
+            <a:r>
+              <a:t>Project Input: What Goes Into SentryOps?</a:t>
+            </a:r>
+          </a:p>
+          <a:p>
+            <a:pPr>
+              <a:defRPr sz="1300" b="0">
+                <a:solidFill>
+                  <a:srgbClr val="38BDF8"/>
+                </a:solidFill>
+                <a:latin typeface="Segoe UI"/>
+              </a:defRPr>
+            </a:pPr>
+            <a:r>
+              <a:t>Production Telemetry, Incident Signals, System Context &amp; Operational Boundaries</a:t>
+            </a:r>
+          </a:p>
+        </p:txBody>
+      </p:sp>
+      <p:sp>
+        <p:nvSpPr>
+          <p:cNvPr id="4" name="Rectangle 3"/>
+          <p:cNvSpPr/>
+          <p:nvPr/>
+        </p:nvSpPr>
+        <p:spPr>
+          <a:xfrm>
+            <a:off x="731520" y="1234440"/>
+            <a:ext cx="10728655" cy="18288"/>
+          </a:xfrm>
+          <a:prstGeom prst="rect">
+            <a:avLst/>
+          </a:prstGeom>
+          <a:solidFill>
+            <a:srgbClr val="334155"/>
+          </a:solidFill>
+          <a:ln>
+            <a:solidFill>
+              <a:srgbClr val="334155"/>
+            </a:solidFill>
+          </a:ln>
+        </p:spPr>
+        <p:style>
+          <a:lnRef idx="1">
+            <a:schemeClr val="accent1"/>
+          </a:lnRef>
+          <a:fillRef idx="3">
+            <a:schemeClr val="accent1"/>
+          </a:fillRef>
+          <a:effectRef idx="2">
+            <a:schemeClr val="accent1"/>
+          </a:effectRef>
+          <a:fontRef idx="minor">
+            <a:schemeClr val="lt1"/>
+          </a:fontRef>
+        </p:style>
+        <p:txBody>
+          <a:bodyPr rtlCol="0" anchor="ctr"/>
+          <a:lstStyle/>
+          <a:p>
+            <a:pPr algn="ctr"/>
+          </a:p>
+        </p:txBody>
+      </p:sp>
+      <p:sp>
+        <p:nvSpPr>
+          <p:cNvPr id="5" name="Rounded Rectangle 4"/>
+          <p:cNvSpPr/>
+          <p:nvPr/>
+        </p:nvSpPr>
+        <p:spPr>
+          <a:xfrm>
+            <a:off x="731520" y="1400000"/>
+            <a:ext cx="5350000" cy="5050000"/>
+          </a:xfrm>
+          <a:prstGeom prst="roundRect">
+            <a:avLst/>
+          </a:prstGeom>
+          <a:solidFill>
+            <a:srgbClr val="1E293B"/>
+          </a:solidFill>
+          <a:ln w="12700">
+            <a:solidFill>
+              <a:srgbClr val="334155"/>
+            </a:solidFill>
+          </a:ln>
+        </p:spPr>
+        <p:style>
+          <a:lnRef idx="1">
+            <a:schemeClr val="accent1"/>
+          </a:lnRef>
+          <a:fillRef idx="3">
+            <a:schemeClr val="accent1"/>
+          </a:fillRef>
+          <a:effectRef idx="2">
+            <a:schemeClr val="accent1"/>
+          </a:effectRef>
+          <a:fontRef idx="minor">
+            <a:schemeClr val="lt1"/>
+          </a:fontRef>
+        </p:style>
+        <p:txBody>
+          <a:bodyPr rtlCol="0" anchor="ctr" wrap="square" lIns="180000" rIns="180000" tIns="180000" bIns="180000"/>
+          <a:lstStyle/>
+          <a:p>
+            <a:pPr algn="ctr">
+              <a:spcAft>
+                <a:spcPts val="150"/>
+              </a:spcAft>
+            </a:pPr>
+            <a:r>
+              <a:rPr sz="1200" b="1">
+                <a:solidFill>
+                  <a:srgbClr val="38BDF8"/>
+                </a:solidFill>
+                <a:latin typeface="Segoe UI"/>
+              </a:rPr>
+              <a:t>• A. </a:t>
+            </a:r>
+            <a:r>
+              <a:rPr sz="1200" b="1">
+                <a:solidFill>
+                  <a:srgbClr val="FFFFFF"/>
+                </a:solidFill>
+                <a:latin typeface="Segoe UI"/>
+              </a:rPr>
+              <a:t>Production Telemetry (Continuous Observability):</a:t>
+            </a:r>
+          </a:p>
+          <a:p>
+            <a:pPr>
+              <a:spcAft>
+                <a:spcPts val="100"/>
+              </a:spcAft>
+            </a:pPr>
+            <a:r>
+              <a:rPr sz="1000">
+                <a:solidFill>
+                  <a:srgbClr val="94A3B8"/>
+                </a:solidFill>
+                <a:latin typeface="Segoe UI"/>
+              </a:rPr>
+              <a:t>   – </a:t>
+            </a:r>
+            <a:r>
+              <a:rPr sz="1000" b="1">
+                <a:solidFill>
+                  <a:srgbClr val="FFFFFF"/>
+                </a:solidFill>
+                <a:latin typeface="Segoe UI"/>
+              </a:rPr>
+              <a:t>Prometheus Metrics: </a:t>
+            </a:r>
+            <a:r>
+              <a:rPr sz="1000">
+                <a:solidFill>
+                  <a:srgbClr val="F1F5F9"/>
+                </a:solidFill>
+                <a:latin typeface="Segoe UI"/>
+              </a:rPr>
+              <a:t>Scrapes request throughput, HTTP 5xx error rate, service health, and P95 latency across all services.</a:t>
+            </a:r>
+          </a:p>
+          <a:p>
+            <a:pPr>
+              <a:spcAft>
+                <a:spcPts val="100"/>
+              </a:spcAft>
+            </a:pPr>
+            <a:r>
+              <a:rPr sz="1000">
+                <a:solidFill>
+                  <a:srgbClr val="94A3B8"/>
+                </a:solidFill>
+                <a:latin typeface="Segoe UI"/>
+              </a:rPr>
+              <a:t>   – </a:t>
+            </a:r>
+            <a:r>
+              <a:rPr sz="1000" b="1">
+                <a:solidFill>
+                  <a:srgbClr val="FFFFFF"/>
+                </a:solidFill>
+                <a:latin typeface="Segoe UI"/>
+              </a:rPr>
+              <a:t>Loki Logs: </a:t>
+            </a:r>
+            <a:r>
+              <a:rPr sz="1000">
+                <a:solidFill>
+                  <a:srgbClr val="F1F5F9"/>
+                </a:solidFill>
+                <a:latin typeface="Segoe UI"/>
+              </a:rPr>
+              <a:t>Streams structured application error events, stack traces, and exception details filtered by service name.</a:t>
+            </a:r>
+          </a:p>
+          <a:p>
+            <a:pPr>
+              <a:spcAft>
+                <a:spcPts val="100"/>
+              </a:spcAft>
+            </a:pPr>
+            <a:r>
+              <a:rPr sz="1000">
+                <a:solidFill>
+                  <a:srgbClr val="94A3B8"/>
+                </a:solidFill>
+                <a:latin typeface="Segoe UI"/>
+              </a:rPr>
+              <a:t>   – </a:t>
+            </a:r>
+            <a:r>
+              <a:rPr sz="1000" b="1">
+                <a:solidFill>
+                  <a:srgbClr val="FFFFFF"/>
+                </a:solidFill>
+                <a:latin typeface="Segoe UI"/>
+              </a:rPr>
+              <a:t>Jaeger Traces: </a:t>
+            </a:r>
+            <a:r>
+              <a:rPr sz="1000">
+                <a:solidFill>
+                  <a:srgbClr val="F1F5F9"/>
+                </a:solidFill>
+                <a:latin typeface="Segoe UI"/>
+              </a:rPr>
+              <a:t>End-to-end distributed traces capturing request execution waterfalls and isolating failed downstream spans.</a:t>
+            </a:r>
+          </a:p>
+          <a:p>
+            <a:pPr>
+              <a:spcBef>
+                <a:spcPts val="600"/>
+              </a:spcBef>
+              <a:spcAft>
+                <a:spcPts val="150"/>
+              </a:spcAft>
+            </a:pPr>
+            <a:r>
+              <a:rPr sz="1200" b="1">
+                <a:solidFill>
+                  <a:srgbClr val="38BDF8"/>
+                </a:solidFill>
+                <a:latin typeface="Segoe UI"/>
+              </a:rPr>
+              <a:t>• B. </a:t>
+            </a:r>
+            <a:r>
+              <a:rPr sz="1200" b="1">
+                <a:solidFill>
+                  <a:srgbClr val="FFFFFF"/>
+                </a:solidFill>
+                <a:latin typeface="Segoe UI"/>
+              </a:rPr>
+              <a:t>Incident &amp; Failure Signals (Anomaly Triggers):</a:t>
+            </a:r>
+          </a:p>
+          <a:p>
+            <a:pPr>
+              <a:spcAft>
+                <a:spcPts val="100"/>
+              </a:spcAft>
+            </a:pPr>
+            <a:r>
+              <a:rPr sz="1000">
+                <a:solidFill>
+                  <a:srgbClr val="94A3B8"/>
+                </a:solidFill>
+                <a:latin typeface="Segoe UI"/>
+              </a:rPr>
+              <a:t>   – </a:t>
+            </a:r>
+            <a:r>
+              <a:rPr sz="1000" b="1">
+                <a:solidFill>
+                  <a:srgbClr val="FFFFFF"/>
+                </a:solidFill>
+                <a:latin typeface="Segoe UI"/>
+              </a:rPr>
+              <a:t>Service Failures: </a:t>
+            </a:r>
+            <a:r>
+              <a:rPr sz="1000">
+                <a:solidFill>
+                  <a:srgbClr val="F1F5F9"/>
+                </a:solidFill>
+                <a:latin typeface="Segoe UI"/>
+              </a:rPr>
+              <a:t>Live microservice outages, error surges, and HTTP 5xx spikes on upstream/downstream routes.</a:t>
+            </a:r>
+          </a:p>
+          <a:p>
+            <a:pPr>
+              <a:spcAft>
+                <a:spcPts val="100"/>
+              </a:spcAft>
+            </a:pPr>
+            <a:r>
+              <a:rPr sz="1000">
+                <a:solidFill>
+                  <a:srgbClr val="94A3B8"/>
+                </a:solidFill>
+                <a:latin typeface="Segoe UI"/>
+              </a:rPr>
+              <a:t>   – </a:t>
+            </a:r>
+            <a:r>
+              <a:rPr sz="1000" b="1">
+                <a:solidFill>
+                  <a:srgbClr val="FFFFFF"/>
+                </a:solidFill>
+                <a:latin typeface="Segoe UI"/>
+              </a:rPr>
+              <a:t>Latency Anomalies: </a:t>
+            </a:r>
+            <a:r>
+              <a:rPr sz="1000">
+                <a:solidFill>
+                  <a:srgbClr val="F1F5F9"/>
+                </a:solidFill>
+                <a:latin typeface="Segoe UI"/>
+              </a:rPr>
+              <a:t>Degraded transaction durations and response timeout spikes detected across active endpoints.</a:t>
+            </a:r>
+          </a:p>
+          <a:p>
+            <a:pPr>
+              <a:spcAft>
+                <a:spcPts val="100"/>
+              </a:spcAft>
+            </a:pPr>
+            <a:r>
+              <a:rPr sz="1000">
+                <a:solidFill>
+                  <a:srgbClr val="94A3B8"/>
+                </a:solidFill>
+                <a:latin typeface="Segoe UI"/>
+              </a:rPr>
+              <a:t>   – </a:t>
+            </a:r>
+            <a:r>
+              <a:rPr sz="1000" b="1">
+                <a:solidFill>
+                  <a:srgbClr val="FFFFFF"/>
+                </a:solidFill>
+                <a:latin typeface="Segoe UI"/>
+              </a:rPr>
+              <a:t>Controlled Fault Injections: </a:t>
+            </a:r>
+            <a:r>
+              <a:rPr sz="1000">
+                <a:solidFill>
+                  <a:srgbClr val="F1F5F9"/>
+                </a:solidFill>
+                <a:latin typeface="Segoe UI"/>
+              </a:rPr>
+              <a:t>Dynamic fault scenarios (`http_500_spike`, crash, latency) injected via port 8005 in controlled demo.</a:t>
+            </a:r>
+          </a:p>
+          <a:p>
+            <a:pPr>
+              <a:spcBef>
+                <a:spcPts val="600"/>
+              </a:spcBef>
+              <a:spcAft>
+                <a:spcPts val="150"/>
+              </a:spcAft>
+            </a:pPr>
+            <a:r>
+              <a:rPr sz="1200" b="1">
+                <a:solidFill>
+                  <a:srgbClr val="38BDF8"/>
+                </a:solidFill>
+                <a:latin typeface="Segoe UI"/>
+              </a:rPr>
+              <a:t>• C. </a:t>
+            </a:r>
+            <a:r>
+              <a:rPr sz="1200" b="1">
+                <a:solidFill>
+                  <a:srgbClr val="FFFFFF"/>
+                </a:solidFill>
+                <a:latin typeface="Segoe UI"/>
+              </a:rPr>
+              <a:t>Incident Context &amp; Knowledge Base (RAG):</a:t>
+            </a:r>
+          </a:p>
+          <a:p>
+            <a:pPr>
+              <a:spcAft>
+                <a:spcPts val="100"/>
+              </a:spcAft>
+            </a:pPr>
+            <a:r>
+              <a:rPr sz="1000">
+                <a:solidFill>
+                  <a:srgbClr val="94A3B8"/>
+                </a:solidFill>
+                <a:latin typeface="Segoe UI"/>
+              </a:rPr>
+              <a:t>   – </a:t>
+            </a:r>
+            <a:r>
+              <a:rPr sz="1000" b="1">
+                <a:solidFill>
+                  <a:srgbClr val="FFFFFF"/>
+                </a:solidFill>
+                <a:latin typeface="Segoe UI"/>
+              </a:rPr>
+              <a:t>Incident Metadata: </a:t>
+            </a:r>
+            <a:r>
+              <a:rPr sz="1000">
+                <a:solidFill>
+                  <a:srgbClr val="F1F5F9"/>
+                </a:solidFill>
+                <a:latin typeface="Segoe UI"/>
+              </a:rPr>
+              <a:t>Unique incident identifiers (`INC-CD90E2`), affected service targets, timestamp, and status.</a:t>
+            </a:r>
+          </a:p>
+          <a:p>
+            <a:pPr>
+              <a:spcAft>
+                <a:spcPts val="100"/>
+              </a:spcAft>
+            </a:pPr>
+            <a:r>
+              <a:rPr sz="1000">
+                <a:solidFill>
+                  <a:srgbClr val="94A3B8"/>
+                </a:solidFill>
+                <a:latin typeface="Segoe UI"/>
+              </a:rPr>
+              <a:t>   – </a:t>
+            </a:r>
+            <a:r>
+              <a:rPr sz="1000" b="1">
+                <a:solidFill>
+                  <a:srgbClr val="FFFFFF"/>
+                </a:solidFill>
+                <a:latin typeface="Segoe UI"/>
+              </a:rPr>
+              <a:t>Collected Evidence: </a:t>
+            </a:r>
+            <a:r>
+              <a:rPr sz="1000">
+                <a:solidFill>
+                  <a:srgbClr val="F1F5F9"/>
+                </a:solidFill>
+                <a:latin typeface="Segoe UI"/>
+              </a:rPr>
+              <a:t>Centralized incident evidence repository aggregating linked metrics, logs, traces, and fault metadata.</a:t>
+            </a:r>
+          </a:p>
+          <a:p>
+            <a:pPr>
+              <a:spcAft>
+                <a:spcPts val="100"/>
+              </a:spcAft>
+            </a:pPr>
+            <a:r>
+              <a:rPr sz="1000">
+                <a:solidFill>
+                  <a:srgbClr val="94A3B8"/>
+                </a:solidFill>
+                <a:latin typeface="Segoe UI"/>
+              </a:rPr>
+              <a:t>   – </a:t>
+            </a:r>
+            <a:r>
+              <a:rPr sz="1000" b="1">
+                <a:solidFill>
+                  <a:srgbClr val="FFFFFF"/>
+                </a:solidFill>
+                <a:latin typeface="Segoe UI"/>
+              </a:rPr>
+              <a:t>Operational Runbooks: </a:t>
+            </a:r>
+            <a:r>
+              <a:rPr sz="1000">
+                <a:solidFill>
+                  <a:srgbClr val="F1F5F9"/>
+                </a:solidFill>
+                <a:latin typeface="Segoe UI"/>
+              </a:rPr>
+              <a:t>Top-k historical postmortems and runbooks retrieved from PostgreSQL using pgvector similarity search.</a:t>
+            </a:r>
+          </a:p>
+          <a:p>
+            <a:pPr>
+              <a:spcBef>
+                <a:spcPts val="600"/>
+              </a:spcBef>
+              <a:spcAft>
+                <a:spcPts val="150"/>
+              </a:spcAft>
+            </a:pPr>
+            <a:r>
+              <a:rPr sz="1200" b="1">
+                <a:solidFill>
+                  <a:srgbClr val="38BDF8"/>
+                </a:solidFill>
+                <a:latin typeface="Segoe UI"/>
+              </a:rPr>
+              <a:t>• D. </a:t>
+            </a:r>
+            <a:r>
+              <a:rPr sz="1200" b="1">
+                <a:solidFill>
+                  <a:srgbClr val="FFFFFF"/>
+                </a:solidFill>
+                <a:latin typeface="Segoe UI"/>
+              </a:rPr>
+              <a:t>Operational Constraints &amp; Policy Boundaries:</a:t>
+            </a:r>
+          </a:p>
+          <a:p>
+            <a:pPr>
+              <a:spcAft>
+                <a:spcPts val="100"/>
+              </a:spcAft>
+            </a:pPr>
+            <a:r>
+              <a:rPr sz="1000">
+                <a:solidFill>
+                  <a:srgbClr val="94A3B8"/>
+                </a:solidFill>
+                <a:latin typeface="Segoe UI"/>
+              </a:rPr>
+              <a:t>   – </a:t>
+            </a:r>
+            <a:r>
+              <a:rPr sz="1000" b="1">
+                <a:solidFill>
+                  <a:srgbClr val="FFFFFF"/>
+                </a:solidFill>
+                <a:latin typeface="Segoe UI"/>
+              </a:rPr>
+              <a:t>Allowlisted Actions: </a:t>
+            </a:r>
+            <a:r>
+              <a:rPr sz="1000">
+                <a:solidFill>
+                  <a:srgbClr val="F1F5F9"/>
+                </a:solidFill>
+                <a:latin typeface="Segoe UI"/>
+              </a:rPr>
+              <a:t>Remediations strictly restricted to `RESTART_SERVICE`, `SCALE_SERVICE`, and `ROLLBACK_SERVICE`.</a:t>
+            </a:r>
+          </a:p>
+          <a:p>
+            <a:pPr>
+              <a:spcAft>
+                <a:spcPts val="100"/>
+              </a:spcAft>
+            </a:pPr>
+            <a:r>
+              <a:rPr sz="1000">
+                <a:solidFill>
+                  <a:srgbClr val="94A3B8"/>
+                </a:solidFill>
+                <a:latin typeface="Segoe UI"/>
+              </a:rPr>
+              <a:t>   – </a:t>
+            </a:r>
+            <a:r>
+              <a:rPr sz="1000" b="1">
+                <a:solidFill>
+                  <a:srgbClr val="FFFFFF"/>
+                </a:solidFill>
+                <a:latin typeface="Segoe UI"/>
+              </a:rPr>
+              <a:t>Risk Policy &amp; Safety: </a:t>
+            </a:r>
+            <a:r>
+              <a:rPr sz="1000">
+                <a:solidFill>
+                  <a:srgbClr val="F1F5F9"/>
+                </a:solidFill>
+                <a:latin typeface="Segoe UI"/>
+              </a:rPr>
+              <a:t>Deterministic parameter validation schemas, risk rules (`LOW`/`MED`/`HIGH`), and approval mandates.</a:t>
+            </a:r>
+          </a:p>
+          <a:p>
+            <a:pPr>
+              <a:spcAft>
+                <a:spcPts val="100"/>
+              </a:spcAft>
+            </a:pPr>
+            <a:r>
+              <a:rPr sz="1000">
+                <a:solidFill>
+                  <a:srgbClr val="94A3B8"/>
+                </a:solidFill>
+                <a:latin typeface="Segoe UI"/>
+              </a:rPr>
+              <a:t>   – </a:t>
+            </a:r>
+            <a:r>
+              <a:rPr sz="1000" b="1">
+                <a:solidFill>
+                  <a:srgbClr val="FFFFFF"/>
+                </a:solidFill>
+                <a:latin typeface="Segoe UI"/>
+              </a:rPr>
+              <a:t>Execution Restrictions: </a:t>
+            </a:r>
+            <a:r>
+              <a:rPr sz="1000">
+                <a:solidFill>
+                  <a:srgbClr val="F1F5F9"/>
+                </a:solidFill>
+                <a:latin typeface="Segoe UI"/>
+              </a:rPr>
+              <a:t>Simulated-only actuation boundaries; zero direct `kubectl` or cluster mutation permitted.</a:t>
+            </a:r>
+          </a:p>
+        </p:txBody>
+      </p:sp>
+      <p:sp>
+        <p:nvSpPr>
+          <p:cNvPr id="6" name="Rounded Rectangle 5"/>
+          <p:cNvSpPr/>
+          <p:nvPr/>
+        </p:nvSpPr>
+        <p:spPr>
+          <a:xfrm>
+            <a:off x="6245352" y="1400000"/>
+            <a:ext cx="5214823" cy="1650000"/>
+          </a:xfrm>
+          <a:prstGeom prst="roundRect">
+            <a:avLst/>
+          </a:prstGeom>
+          <a:solidFill>
+            <a:srgbClr val="0F233D"/>
+          </a:solidFill>
+          <a:ln w="12700">
+            <a:solidFill>
+              <a:srgbClr val="0284C7"/>
+            </a:solidFill>
+          </a:ln>
+        </p:spPr>
+        <p:style>
+          <a:lnRef idx="1">
+            <a:schemeClr val="accent1"/>
+          </a:lnRef>
+          <a:fillRef idx="3">
+            <a:schemeClr val="accent1"/>
+          </a:fillRef>
+          <a:effectRef idx="2">
+            <a:schemeClr val="accent1"/>
+          </a:effectRef>
+          <a:fontRef idx="minor">
+            <a:schemeClr val="lt1"/>
+          </a:fontRef>
+        </p:style>
+        <p:txBody>
+          <a:bodyPr rtlCol="0" anchor="ctr" wrap="square" lIns="150000" rIns="150000" tIns="150000" bIns="150000"/>
+          <a:lstStyle/>
+          <a:p>
+            <a:pPr algn="ctr">
+              <a:spcAft>
+                <a:spcPts val="300"/>
+              </a:spcAft>
+            </a:pPr>
+            <a:r>
+              <a:rPr sz="1150" b="1">
+                <a:solidFill>
+                  <a:srgbClr val="38BDF8"/>
+                </a:solidFill>
+                <a:latin typeface="Segoe UI"/>
+              </a:rPr>
+              <a:t>INGESTION &amp; INVESTIGATION PIPELINE FLOW</a:t>
+            </a:r>
+          </a:p>
+          <a:p>
+            <a:pPr>
+              <a:spcAft>
+                <a:spcPts val="300"/>
+              </a:spcAft>
+            </a:pPr>
+            <a:r>
+              <a:rPr sz="1000" b="1">
+                <a:solidFill>
+                  <a:srgbClr val="FFFFFF"/>
+                </a:solidFill>
+                <a:latin typeface="Segoe UI"/>
+              </a:rPr>
+              <a:t>Metrics + Logs + Traces + Incident Context  ➔  SentryOps Investigation Pipeline</a:t>
+            </a:r>
+          </a:p>
+          <a:p>
+            <a:pPr>
+              <a:spcAft>
+                <a:spcPts val="200"/>
+              </a:spcAft>
+            </a:pPr>
+            <a:r>
+              <a:rPr sz="850">
+                <a:solidFill>
+                  <a:srgbClr val="38BDF8"/>
+                </a:solidFill>
+                <a:latin typeface="Consolas"/>
+              </a:rPr>
+              <a:t>┌─────────────────────────────┐   ┌─────────────────────────────┐
+│ Telemetry: Prom + Loki + Jg │ + │ Context: Faults + Runbooks  │
+└──────────────┬──────────────┘   └──────────────┬──────────────┘
+               └───────────────┬─────────────────┘
+                               ▼
+   [ LangGraph Multi-Agent Parallel Investigation Engine ]</a:t>
+            </a:r>
+          </a:p>
+        </p:txBody>
+      </p:sp>
+      <p:sp>
+        <p:nvSpPr>
+          <p:cNvPr id="7" name="Rounded Rectangle 6"/>
+          <p:cNvSpPr/>
+          <p:nvPr/>
+        </p:nvSpPr>
+        <p:spPr>
+          <a:xfrm>
+            <a:off x="6245352" y="3150000"/>
+            <a:ext cx="5214823" cy="3300000"/>
+          </a:xfrm>
+          <a:prstGeom prst="roundRect">
+            <a:avLst/>
+          </a:prstGeom>
+          <a:solidFill>
+            <a:srgbClr val="1E293B"/>
+          </a:solidFill>
+          <a:ln w="12700">
+            <a:solidFill>
+              <a:srgbClr val="334155"/>
+            </a:solidFill>
+          </a:ln>
+        </p:spPr>
+        <p:style>
+          <a:lnRef idx="1">
+            <a:schemeClr val="accent1"/>
+          </a:lnRef>
+          <a:fillRef idx="3">
+            <a:schemeClr val="accent1"/>
+          </a:fillRef>
+          <a:effectRef idx="2">
+            <a:schemeClr val="accent1"/>
+          </a:effectRef>
+          <a:fontRef idx="minor">
+            <a:schemeClr val="lt1"/>
+          </a:fontRef>
+        </p:style>
+        <p:txBody>
+          <a:bodyPr rtlCol="0" anchor="ctr" wrap="square" lIns="180000" rIns="180000" tIns="180000" bIns="180000"/>
+          <a:lstStyle/>
+          <a:p>
+            <a:pPr algn="ctr">
+              <a:spcAft>
+                <a:spcPts val="500"/>
+              </a:spcAft>
+            </a:pPr>
+            <a:r>
+              <a:rPr sz="1150" b="1">
+                <a:solidFill>
+                  <a:srgbClr val="FBBF24"/>
+                </a:solidFill>
+                <a:latin typeface="Segoe UI"/>
+              </a:rPr>
+              <a:t>CONCRETE DEMO INPUT EXAMPLE (INC-CD90E2)</a:t>
+            </a:r>
+          </a:p>
+          <a:p>
+            <a:pPr>
+              <a:spcAft>
+                <a:spcPts val="300"/>
+              </a:spcAft>
+            </a:pPr>
+            <a:r>
+              <a:rPr sz="1000" b="1">
+                <a:solidFill>
+                  <a:srgbClr val="FFFFFF"/>
+                </a:solidFill>
+                <a:latin typeface="Segoe UI"/>
+              </a:rPr>
+              <a:t>• Controlled Scenario: </a:t>
+            </a:r>
+            <a:r>
+              <a:rPr sz="1000">
+                <a:solidFill>
+                  <a:srgbClr val="F1F5F9"/>
+                </a:solidFill>
+                <a:latin typeface="Segoe UI"/>
+              </a:rPr>
+              <a:t>Payment service begins returning HTTP 500 errors during controlled `http_500_spike` experiment (`FAULT-1D8A4DA5`, `error_rate: 1.0`).</a:t>
+            </a:r>
+          </a:p>
+          <a:p>
+            <a:pPr>
+              <a:spcAft>
+                <a:spcPts val="300"/>
+              </a:spcAft>
+            </a:pPr>
+            <a:r>
+              <a:rPr sz="1000" b="1">
+                <a:solidFill>
+                  <a:srgbClr val="FFFFFF"/>
+                </a:solidFill>
+                <a:latin typeface="Segoe UI"/>
+              </a:rPr>
+              <a:t>• Prometheus Telemetry: </a:t>
+            </a:r>
+            <a:r>
+              <a:rPr sz="1000">
+                <a:solidFill>
+                  <a:srgbClr val="F1F5F9"/>
+                </a:solidFill>
+                <a:latin typeface="Segoe UI"/>
+              </a:rPr>
+              <a:t>10/10 order requests fail with HTTP 500. Error rate spikes to 100%; avg latency drops to 1.008s due to fast-failing responses.</a:t>
+            </a:r>
+          </a:p>
+          <a:p>
+            <a:pPr>
+              <a:spcAft>
+                <a:spcPts val="300"/>
+              </a:spcAft>
+            </a:pPr>
+            <a:r>
+              <a:rPr sz="1000" b="1">
+                <a:solidFill>
+                  <a:srgbClr val="FFFFFF"/>
+                </a:solidFill>
+                <a:latin typeface="Segoe UI"/>
+              </a:rPr>
+              <a:t>• Loki Error Logs: </a:t>
+            </a:r>
+            <a:r>
+              <a:rPr sz="1000">
+                <a:solidFill>
+                  <a:srgbClr val="F1F5F9"/>
+                </a:solidFill>
+                <a:latin typeface="Segoe UI"/>
+              </a:rPr>
+              <a:t>Captures structured HTTP 500 Internal Server Error logs and exception stack traces originating from `payment-service` pod.</a:t>
+            </a:r>
+          </a:p>
+          <a:p>
+            <a:pPr>
+              <a:spcAft>
+                <a:spcPts val="300"/>
+              </a:spcAft>
+            </a:pPr>
+            <a:r>
+              <a:rPr sz="1000" b="1">
+                <a:solidFill>
+                  <a:srgbClr val="FFFFFF"/>
+                </a:solidFill>
+                <a:latin typeface="Segoe UI"/>
+              </a:rPr>
+              <a:t>• Jaeger Traces (`EV-TRACE-3F77AC`): </a:t>
+            </a:r>
+            <a:r>
+              <a:rPr sz="1000">
+                <a:solidFill>
+                  <a:srgbClr val="F1F5F9"/>
+                </a:solidFill>
+                <a:latin typeface="Segoe UI"/>
+              </a:rPr>
+              <a:t>Harvests 10 traces across transaction graph, isolating 7 downstream HTTP spans with `error=true` tags.</a:t>
+            </a:r>
+          </a:p>
+          <a:p>
+            <a:pPr>
+              <a:spcAft>
+                <a:spcPts val="300"/>
+              </a:spcAft>
+            </a:pPr>
+            <a:r>
+              <a:rPr sz="1000" b="1">
+                <a:solidFill>
+                  <a:srgbClr val="FFFFFF"/>
+                </a:solidFill>
+                <a:latin typeface="Segoe UI"/>
+              </a:rPr>
+              <a:t>• Context &amp; Runbooks: </a:t>
+            </a:r>
+            <a:r>
+              <a:rPr sz="1000">
+                <a:solidFill>
+                  <a:srgbClr val="F1F5F9"/>
+                </a:solidFill>
+                <a:latin typeface="Segoe UI"/>
+              </a:rPr>
+              <a:t>Correlates active synthetic fault metadata (`EV-CHANGE-9964BD`), pod health (`EV-INFRA-5B1A7A`), and 3 pgvector runbooks (`EVID-KNOW-6750`).</a:t>
+            </a:r>
+          </a:p>
+        </p:txBody>
+      </p:sp>
+    </p:spTree>
+  </p:cSld>
+  <p:clrMapOvr>
+    <a:masterClrMapping/>
+  </p:clrMapOvr>
+</p:sld>
+</file>
+
+<file path=ppt/slides/slide13.xml><?xml version="1.0" encoding="utf-8"?>
+<p:sld xmlns:a="http://schemas.openxmlformats.org/drawingml/2006/main" xmlns:p="http://schemas.openxmlformats.org/presentationml/2006/main" xmlns:r="http://schemas.openxmlformats.org/officeDocument/2006/relationships">
+  <p:cSld>
+    <p:spTree>
+      <p:nvGrpSpPr>
+        <p:cNvPr id="1" name=""/>
+        <p:cNvGrpSpPr/>
+        <p:nvPr/>
+      </p:nvGrpSpPr>
+      <p:grpSpPr/>
+      <p:sp>
+        <p:nvSpPr>
+          <p:cNvPr id="2" name="Rectangle 1"/>
+          <p:cNvSpPr/>
+          <p:nvPr/>
+        </p:nvSpPr>
+        <p:spPr>
+          <a:xfrm>
+            <a:off x="0" y="0"/>
+            <a:ext cx="12191695" cy="6858000"/>
+          </a:xfrm>
+          <a:prstGeom prst="rect">
+            <a:avLst/>
+          </a:prstGeom>
+          <a:solidFill>
+            <a:srgbClr val="0F172A"/>
+          </a:solidFill>
+          <a:ln>
+            <a:solidFill>
+              <a:srgbClr val="0F172A"/>
+            </a:solidFill>
+          </a:ln>
+        </p:spPr>
+        <p:style>
+          <a:lnRef idx="1">
+            <a:schemeClr val="accent1"/>
+          </a:lnRef>
+          <a:fillRef idx="3">
+            <a:schemeClr val="accent1"/>
+          </a:fillRef>
+          <a:effectRef idx="2">
+            <a:schemeClr val="accent1"/>
+          </a:effectRef>
+          <a:fontRef idx="minor">
+            <a:schemeClr val="lt1"/>
+          </a:fontRef>
+        </p:style>
+        <p:txBody>
+          <a:bodyPr rtlCol="0" anchor="ctr"/>
+          <a:lstStyle/>
+          <a:p>
+            <a:pPr algn="ctr"/>
+          </a:p>
+        </p:txBody>
+      </p:sp>
+      <p:sp>
+        <p:nvSpPr>
+          <p:cNvPr id="3" name="TextBox 2"/>
+          <p:cNvSpPr txBox="1"/>
+          <p:nvPr/>
+        </p:nvSpPr>
+        <p:spPr>
+          <a:xfrm>
+            <a:off x="731520" y="365760"/>
+            <a:ext cx="10728655" cy="868680"/>
+          </a:xfrm>
+          <a:prstGeom prst="rect">
+            <a:avLst/>
+          </a:prstGeom>
+          <a:noFill/>
+        </p:spPr>
+        <p:txBody>
+          <a:bodyPr wrap="square" lIns="0" rIns="0" tIns="0" bIns="0">
+            <a:spAutoFit/>
+          </a:bodyPr>
+          <a:lstStyle/>
+          <a:p>
+            <a:pPr>
+              <a:spcAft>
+                <a:spcPts val="300"/>
+              </a:spcAft>
+              <a:defRPr sz="2400" b="1">
+                <a:solidFill>
+                  <a:srgbClr val="FFFFFF"/>
+                </a:solidFill>
+                <a:latin typeface="Segoe UI"/>
+              </a:defRPr>
+            </a:pPr>
+            <a:r>
+              <a:t>Project Output: What Does SentryOps Produce?</a:t>
+            </a:r>
+          </a:p>
+          <a:p>
+            <a:pPr>
+              <a:defRPr sz="1300" b="0">
+                <a:solidFill>
+                  <a:srgbClr val="38BDF8"/>
+                </a:solidFill>
+                <a:latin typeface="Segoe UI"/>
+              </a:defRPr>
+            </a:pPr>
+            <a:r>
+              <a:t>Root Cause Diagnosis, Remediation Proposals, Safety Decisions &amp; Verification Outcomes</a:t>
+            </a:r>
+          </a:p>
+        </p:txBody>
+      </p:sp>
+      <p:sp>
+        <p:nvSpPr>
+          <p:cNvPr id="4" name="Rectangle 3"/>
+          <p:cNvSpPr/>
+          <p:nvPr/>
+        </p:nvSpPr>
+        <p:spPr>
+          <a:xfrm>
+            <a:off x="731520" y="1234440"/>
+            <a:ext cx="10728655" cy="18288"/>
+          </a:xfrm>
+          <a:prstGeom prst="rect">
+            <a:avLst/>
+          </a:prstGeom>
+          <a:solidFill>
+            <a:srgbClr val="334155"/>
+          </a:solidFill>
+          <a:ln>
+            <a:solidFill>
+              <a:srgbClr val="334155"/>
+            </a:solidFill>
+          </a:ln>
+        </p:spPr>
+        <p:style>
+          <a:lnRef idx="1">
+            <a:schemeClr val="accent1"/>
+          </a:lnRef>
+          <a:fillRef idx="3">
+            <a:schemeClr val="accent1"/>
+          </a:fillRef>
+          <a:effectRef idx="2">
+            <a:schemeClr val="accent1"/>
+          </a:effectRef>
+          <a:fontRef idx="minor">
+            <a:schemeClr val="lt1"/>
+          </a:fontRef>
+        </p:style>
+        <p:txBody>
+          <a:bodyPr rtlCol="0" anchor="ctr"/>
+          <a:lstStyle/>
+          <a:p>
+            <a:pPr algn="ctr"/>
+          </a:p>
+        </p:txBody>
+      </p:sp>
+      <p:sp>
+        <p:nvSpPr>
+          <p:cNvPr id="5" name="Rounded Rectangle 4"/>
+          <p:cNvSpPr/>
+          <p:nvPr/>
+        </p:nvSpPr>
+        <p:spPr>
+          <a:xfrm>
+            <a:off x="731520" y="1400000"/>
+            <a:ext cx="5350000" cy="5050000"/>
+          </a:xfrm>
+          <a:prstGeom prst="roundRect">
+            <a:avLst/>
+          </a:prstGeom>
+          <a:solidFill>
+            <a:srgbClr val="1E293B"/>
+          </a:solidFill>
+          <a:ln w="12700">
+            <a:solidFill>
+              <a:srgbClr val="334155"/>
+            </a:solidFill>
+          </a:ln>
+        </p:spPr>
+        <p:style>
+          <a:lnRef idx="1">
+            <a:schemeClr val="accent1"/>
+          </a:lnRef>
+          <a:fillRef idx="3">
+            <a:schemeClr val="accent1"/>
+          </a:fillRef>
+          <a:effectRef idx="2">
+            <a:schemeClr val="accent1"/>
+          </a:effectRef>
+          <a:fontRef idx="minor">
+            <a:schemeClr val="lt1"/>
+          </a:fontRef>
+        </p:style>
+        <p:txBody>
+          <a:bodyPr rtlCol="0" anchor="ctr" wrap="square" lIns="180000" rIns="180000" tIns="180000" bIns="180000"/>
+          <a:lstStyle/>
+          <a:p>
+            <a:pPr algn="ctr">
+              <a:spcAft>
+                <a:spcPts val="150"/>
+              </a:spcAft>
+            </a:pPr>
+            <a:r>
+              <a:rPr sz="1200" b="1">
+                <a:solidFill>
+                  <a:srgbClr val="38BDF8"/>
+                </a:solidFill>
+                <a:latin typeface="Segoe UI"/>
+              </a:rPr>
+              <a:t>• A. </a:t>
+            </a:r>
+            <a:r>
+              <a:rPr sz="1200" b="1">
+                <a:solidFill>
+                  <a:srgbClr val="FFFFFF"/>
+                </a:solidFill>
+                <a:latin typeface="Segoe UI"/>
+              </a:rPr>
+              <a:t>Incident Diagnosis &amp; Root Cause Analysis (RCA):</a:t>
+            </a:r>
+          </a:p>
+          <a:p>
+            <a:pPr>
+              <a:spcAft>
+                <a:spcPts val="100"/>
+              </a:spcAft>
+            </a:pPr>
+            <a:r>
+              <a:rPr sz="1000">
+                <a:solidFill>
+                  <a:srgbClr val="94A3B8"/>
+                </a:solidFill>
+                <a:latin typeface="Segoe UI"/>
+              </a:rPr>
+              <a:t>   – </a:t>
+            </a:r>
+            <a:r>
+              <a:rPr sz="1000" b="1">
+                <a:solidFill>
+                  <a:srgbClr val="FFFFFF"/>
+                </a:solidFill>
+                <a:latin typeface="Segoe UI"/>
+              </a:rPr>
+              <a:t>Incident Attribution: </a:t>
+            </a:r>
+            <a:r>
+              <a:rPr sz="1000">
+                <a:solidFill>
+                  <a:srgbClr val="F1F5F9"/>
+                </a:solidFill>
+                <a:latin typeface="Segoe UI"/>
+              </a:rPr>
+              <a:t>Pinpoints affected microservice (`payment-service`), root cause classification, and confidence score.</a:t>
+            </a:r>
+          </a:p>
+          <a:p>
+            <a:pPr>
+              <a:spcAft>
+                <a:spcPts val="100"/>
+              </a:spcAft>
+            </a:pPr>
+            <a:r>
+              <a:rPr sz="1000">
+                <a:solidFill>
+                  <a:srgbClr val="94A3B8"/>
+                </a:solidFill>
+                <a:latin typeface="Segoe UI"/>
+              </a:rPr>
+              <a:t>   – </a:t>
+            </a:r>
+            <a:r>
+              <a:rPr sz="1000" b="1">
+                <a:solidFill>
+                  <a:srgbClr val="FFFFFF"/>
+                </a:solidFill>
+                <a:latin typeface="Segoe UI"/>
+              </a:rPr>
+              <a:t>Evidence Linkage: </a:t>
+            </a:r>
+            <a:r>
+              <a:rPr sz="1000">
+                <a:solidFill>
+                  <a:srgbClr val="F1F5F9"/>
+                </a:solidFill>
+                <a:latin typeface="Segoe UI"/>
+              </a:rPr>
+              <a:t>Grounds diagnosis in verified telemetry (`EV-TRACE-3F77AC`, `EV-CHANGE-9964BD`, `EV-INFRA-5B1A7A`).</a:t>
+            </a:r>
+          </a:p>
+          <a:p>
+            <a:pPr>
+              <a:spcAft>
+                <a:spcPts val="100"/>
+              </a:spcAft>
+            </a:pPr>
+            <a:r>
+              <a:rPr sz="1000">
+                <a:solidFill>
+                  <a:srgbClr val="94A3B8"/>
+                </a:solidFill>
+                <a:latin typeface="Segoe UI"/>
+              </a:rPr>
+              <a:t>   – </a:t>
+            </a:r>
+            <a:r>
+              <a:rPr sz="1000" b="1">
+                <a:solidFill>
+                  <a:srgbClr val="FFFFFF"/>
+                </a:solidFill>
+                <a:latin typeface="Segoe UI"/>
+              </a:rPr>
+              <a:t>Anti-Hallucination Gate: </a:t>
+            </a:r>
+            <a:r>
+              <a:rPr sz="1000">
+                <a:solidFill>
+                  <a:srgbClr val="F1F5F9"/>
+                </a:solidFill>
+                <a:latin typeface="Segoe UI"/>
+              </a:rPr>
+              <a:t>Strictly validates that all cited evidence IDs exist in the incident evidence store before finalizing RCA.</a:t>
+            </a:r>
+          </a:p>
+          <a:p>
+            <a:pPr>
+              <a:spcBef>
+                <a:spcPts val="600"/>
+              </a:spcBef>
+              <a:spcAft>
+                <a:spcPts val="150"/>
+              </a:spcAft>
+            </a:pPr>
+            <a:r>
+              <a:rPr sz="1200" b="1">
+                <a:solidFill>
+                  <a:srgbClr val="38BDF8"/>
+                </a:solidFill>
+                <a:latin typeface="Segoe UI"/>
+              </a:rPr>
+              <a:t>• B. </a:t>
+            </a:r>
+            <a:r>
+              <a:rPr sz="1200" b="1">
+                <a:solidFill>
+                  <a:srgbClr val="FFFFFF"/>
+                </a:solidFill>
+                <a:latin typeface="Segoe UI"/>
+              </a:rPr>
+              <a:t>Structured Remediation Proposal:</a:t>
+            </a:r>
+          </a:p>
+          <a:p>
+            <a:pPr>
+              <a:spcAft>
+                <a:spcPts val="100"/>
+              </a:spcAft>
+            </a:pPr>
+            <a:r>
+              <a:rPr sz="1000">
+                <a:solidFill>
+                  <a:srgbClr val="94A3B8"/>
+                </a:solidFill>
+                <a:latin typeface="Segoe UI"/>
+              </a:rPr>
+              <a:t>   – </a:t>
+            </a:r>
+            <a:r>
+              <a:rPr sz="1000" b="1">
+                <a:solidFill>
+                  <a:srgbClr val="FFFFFF"/>
+                </a:solidFill>
+                <a:latin typeface="Segoe UI"/>
+              </a:rPr>
+              <a:t>Allowlisted Proposal: </a:t>
+            </a:r>
+            <a:r>
+              <a:rPr sz="1000">
+                <a:solidFill>
+                  <a:srgbClr val="F1F5F9"/>
+                </a:solidFill>
+                <a:latin typeface="Segoe UI"/>
+              </a:rPr>
+              <a:t>Generates safe remediation action: `SCALE_SERVICE` for `payment-service` (`replicas: 2`).</a:t>
+            </a:r>
+          </a:p>
+          <a:p>
+            <a:pPr>
+              <a:spcAft>
+                <a:spcPts val="100"/>
+              </a:spcAft>
+            </a:pPr>
+            <a:r>
+              <a:rPr sz="1000">
+                <a:solidFill>
+                  <a:srgbClr val="94A3B8"/>
+                </a:solidFill>
+                <a:latin typeface="Segoe UI"/>
+              </a:rPr>
+              <a:t>   – </a:t>
+            </a:r>
+            <a:r>
+              <a:rPr sz="1000" b="1">
+                <a:solidFill>
+                  <a:srgbClr val="FFFFFF"/>
+                </a:solidFill>
+                <a:latin typeface="Segoe UI"/>
+              </a:rPr>
+              <a:t>Deterministic Risk Rating: </a:t>
+            </a:r>
+            <a:r>
+              <a:rPr sz="1000">
+                <a:solidFill>
+                  <a:srgbClr val="F1F5F9"/>
+                </a:solidFill>
+                <a:latin typeface="Segoe UI"/>
+              </a:rPr>
+              <a:t>Classified as `MEDIUM` risk by non-LLM policy engine based on parameter scope.</a:t>
+            </a:r>
+          </a:p>
+          <a:p>
+            <a:pPr>
+              <a:spcAft>
+                <a:spcPts val="100"/>
+              </a:spcAft>
+            </a:pPr>
+            <a:r>
+              <a:rPr sz="1000">
+                <a:solidFill>
+                  <a:srgbClr val="94A3B8"/>
+                </a:solidFill>
+                <a:latin typeface="Segoe UI"/>
+              </a:rPr>
+              <a:t>   – </a:t>
+            </a:r>
+            <a:r>
+              <a:rPr sz="1000" b="1">
+                <a:solidFill>
+                  <a:srgbClr val="FFFFFF"/>
+                </a:solidFill>
+                <a:latin typeface="Segoe UI"/>
+              </a:rPr>
+              <a:t>Mandatory Human Gate: </a:t>
+            </a:r>
+            <a:r>
+              <a:rPr sz="1000">
+                <a:solidFill>
+                  <a:srgbClr val="F1F5F9"/>
+                </a:solidFill>
+                <a:latin typeface="Segoe UI"/>
+              </a:rPr>
+              <a:t>Enforces `requires_approval: true`, automatically halting workflow at `PENDING_APPROVAL`.</a:t>
+            </a:r>
+          </a:p>
+          <a:p>
+            <a:pPr>
+              <a:spcBef>
+                <a:spcPts val="600"/>
+              </a:spcBef>
+              <a:spcAft>
+                <a:spcPts val="150"/>
+              </a:spcAft>
+            </a:pPr>
+            <a:r>
+              <a:rPr sz="1200" b="1">
+                <a:solidFill>
+                  <a:srgbClr val="38BDF8"/>
+                </a:solidFill>
+                <a:latin typeface="Segoe UI"/>
+              </a:rPr>
+              <a:t>• C. </a:t>
+            </a:r>
+            <a:r>
+              <a:rPr sz="1200" b="1">
+                <a:solidFill>
+                  <a:srgbClr val="FFFFFF"/>
+                </a:solidFill>
+                <a:latin typeface="Segoe UI"/>
+              </a:rPr>
+              <a:t>Safety Decision &amp; Execution Result:</a:t>
+            </a:r>
+          </a:p>
+          <a:p>
+            <a:pPr>
+              <a:spcAft>
+                <a:spcPts val="100"/>
+              </a:spcAft>
+            </a:pPr>
+            <a:r>
+              <a:rPr sz="1000">
+                <a:solidFill>
+                  <a:srgbClr val="94A3B8"/>
+                </a:solidFill>
+                <a:latin typeface="Segoe UI"/>
+              </a:rPr>
+              <a:t>   – </a:t>
+            </a:r>
+            <a:r>
+              <a:rPr sz="1000" b="1">
+                <a:solidFill>
+                  <a:srgbClr val="FFFFFF"/>
+                </a:solidFill>
+                <a:latin typeface="Segoe UI"/>
+              </a:rPr>
+              <a:t>Approval / Rejection Status: </a:t>
+            </a:r>
+            <a:r>
+              <a:rPr sz="1000">
+                <a:solidFill>
+                  <a:srgbClr val="F1F5F9"/>
+                </a:solidFill>
+                <a:latin typeface="Segoe UI"/>
+              </a:rPr>
+              <a:t>Audit trail records operator decision (`APPROVED` or `REJECTED`) with decision timestamps.</a:t>
+            </a:r>
+          </a:p>
+          <a:p>
+            <a:pPr>
+              <a:spcAft>
+                <a:spcPts val="100"/>
+              </a:spcAft>
+            </a:pPr>
+            <a:r>
+              <a:rPr sz="1000">
+                <a:solidFill>
+                  <a:srgbClr val="94A3B8"/>
+                </a:solidFill>
+                <a:latin typeface="Segoe UI"/>
+              </a:rPr>
+              <a:t>   – </a:t>
+            </a:r>
+            <a:r>
+              <a:rPr sz="1000" b="1">
+                <a:solidFill>
+                  <a:srgbClr val="FFFFFF"/>
+                </a:solidFill>
+                <a:latin typeface="Segoe UI"/>
+              </a:rPr>
+              <a:t>Simulated Execution Status: </a:t>
+            </a:r>
+            <a:r>
+              <a:rPr sz="1000">
+                <a:solidFill>
+                  <a:srgbClr val="F1F5F9"/>
+                </a:solidFill>
+                <a:latin typeface="Segoe UI"/>
+              </a:rPr>
+              <a:t>Execution status: `SUCCESS` applied strictly against in-memory `SIMULATED_INFRA_STATE`.</a:t>
+            </a:r>
+          </a:p>
+          <a:p>
+            <a:pPr>
+              <a:spcAft>
+                <a:spcPts val="100"/>
+              </a:spcAft>
+            </a:pPr>
+            <a:r>
+              <a:rPr sz="1000">
+                <a:solidFill>
+                  <a:srgbClr val="94A3B8"/>
+                </a:solidFill>
+                <a:latin typeface="Segoe UI"/>
+              </a:rPr>
+              <a:t>   – </a:t>
+            </a:r>
+            <a:r>
+              <a:rPr sz="1000" b="1">
+                <a:solidFill>
+                  <a:srgbClr val="FFFFFF"/>
+                </a:solidFill>
+                <a:latin typeface="Segoe UI"/>
+              </a:rPr>
+              <a:t>No Live Cluster Mutation: </a:t>
+            </a:r>
+            <a:r>
+              <a:rPr sz="1000">
+                <a:solidFill>
+                  <a:srgbClr val="F1F5F9"/>
+                </a:solidFill>
+                <a:latin typeface="Segoe UI"/>
+              </a:rPr>
+              <a:t>Explicit boundary: Remediation updates simulated state only; `kubectl get deployment` remains at 1 replica.</a:t>
+            </a:r>
+          </a:p>
+          <a:p>
+            <a:pPr>
+              <a:spcBef>
+                <a:spcPts val="600"/>
+              </a:spcBef>
+              <a:spcAft>
+                <a:spcPts val="150"/>
+              </a:spcAft>
+            </a:pPr>
+            <a:r>
+              <a:rPr sz="1200" b="1">
+                <a:solidFill>
+                  <a:srgbClr val="38BDF8"/>
+                </a:solidFill>
+                <a:latin typeface="Segoe UI"/>
+              </a:rPr>
+              <a:t>• D. </a:t>
+            </a:r>
+            <a:r>
+              <a:rPr sz="1200" b="1">
+                <a:solidFill>
+                  <a:srgbClr val="FFFFFF"/>
+                </a:solidFill>
+                <a:latin typeface="Segoe UI"/>
+              </a:rPr>
+              <a:t>Verification &amp; Incident Outcome:</a:t>
+            </a:r>
+          </a:p>
+          <a:p>
+            <a:pPr>
+              <a:spcAft>
+                <a:spcPts val="100"/>
+              </a:spcAft>
+            </a:pPr>
+            <a:r>
+              <a:rPr sz="1000">
+                <a:solidFill>
+                  <a:srgbClr val="94A3B8"/>
+                </a:solidFill>
+                <a:latin typeface="Segoe UI"/>
+              </a:rPr>
+              <a:t>   – </a:t>
+            </a:r>
+            <a:r>
+              <a:rPr sz="1000" b="1">
+                <a:solidFill>
+                  <a:srgbClr val="FFFFFF"/>
+                </a:solidFill>
+                <a:latin typeface="Segoe UI"/>
+              </a:rPr>
+              <a:t>Deterministic Verification: </a:t>
+            </a:r>
+            <a:r>
+              <a:rPr sz="1000">
+                <a:solidFill>
+                  <a:srgbClr val="F1F5F9"/>
+                </a:solidFill>
+                <a:latin typeface="Segoe UI"/>
+              </a:rPr>
+              <a:t>Automated checks confirm simulated replica count (2) and healthy status (`VERIFIED_SUCCESS`).</a:t>
+            </a:r>
+          </a:p>
+          <a:p>
+            <a:pPr>
+              <a:spcAft>
+                <a:spcPts val="100"/>
+              </a:spcAft>
+            </a:pPr>
+            <a:r>
+              <a:rPr sz="1000">
+                <a:solidFill>
+                  <a:srgbClr val="94A3B8"/>
+                </a:solidFill>
+                <a:latin typeface="Segoe UI"/>
+              </a:rPr>
+              <a:t>   – </a:t>
+            </a:r>
+            <a:r>
+              <a:rPr sz="1000" b="1">
+                <a:solidFill>
+                  <a:srgbClr val="FFFFFF"/>
+                </a:solidFill>
+                <a:latin typeface="Segoe UI"/>
+              </a:rPr>
+              <a:t>Lifecycle Resolution: </a:t>
+            </a:r>
+            <a:r>
+              <a:rPr sz="1000">
+                <a:solidFill>
+                  <a:srgbClr val="F1F5F9"/>
+                </a:solidFill>
+                <a:latin typeface="Segoe UI"/>
+              </a:rPr>
+              <a:t>Approved incidents transition to `RESOLVED`; rejected incidents cancel execution and remain `INVESTIGATING`.</a:t>
+            </a:r>
+          </a:p>
+          <a:p>
+            <a:pPr>
+              <a:spcAft>
+                <a:spcPts val="100"/>
+              </a:spcAft>
+            </a:pPr>
+            <a:r>
+              <a:rPr sz="1000">
+                <a:solidFill>
+                  <a:srgbClr val="94A3B8"/>
+                </a:solidFill>
+                <a:latin typeface="Segoe UI"/>
+              </a:rPr>
+              <a:t>   – </a:t>
+            </a:r>
+            <a:r>
+              <a:rPr sz="1000" b="1">
+                <a:solidFill>
+                  <a:srgbClr val="FFFFFF"/>
+                </a:solidFill>
+                <a:latin typeface="Segoe UI"/>
+              </a:rPr>
+              <a:t>Audit Postmortem &amp; Evaluation: </a:t>
+            </a:r>
+            <a:r>
+              <a:rPr sz="1000">
+                <a:solidFill>
+                  <a:srgbClr val="F1F5F9"/>
+                </a:solidFill>
+                <a:latin typeface="Segoe UI"/>
+              </a:rPr>
+              <a:t>Generates 9-section structured postmortem deterministically; passes all 4 evaluation dimensions.</a:t>
+            </a:r>
+          </a:p>
+        </p:txBody>
+      </p:sp>
+      <p:sp>
+        <p:nvSpPr>
+          <p:cNvPr id="6" name="Rounded Rectangle 5"/>
+          <p:cNvSpPr/>
+          <p:nvPr/>
+        </p:nvSpPr>
+        <p:spPr>
+          <a:xfrm>
+            <a:off x="6245352" y="1400000"/>
+            <a:ext cx="5214823" cy="1750000"/>
+          </a:xfrm>
+          <a:prstGeom prst="roundRect">
+            <a:avLst/>
+          </a:prstGeom>
+          <a:solidFill>
+            <a:srgbClr val="0F233D"/>
+          </a:solidFill>
+          <a:ln w="12700">
+            <a:solidFill>
+              <a:srgbClr val="0284C7"/>
+            </a:solidFill>
+          </a:ln>
+        </p:spPr>
+        <p:style>
+          <a:lnRef idx="1">
+            <a:schemeClr val="accent1"/>
+          </a:lnRef>
+          <a:fillRef idx="3">
+            <a:schemeClr val="accent1"/>
+          </a:fillRef>
+          <a:effectRef idx="2">
+            <a:schemeClr val="accent1"/>
+          </a:effectRef>
+          <a:fontRef idx="minor">
+            <a:schemeClr val="lt1"/>
+          </a:fontRef>
+        </p:style>
+        <p:txBody>
+          <a:bodyPr rtlCol="0" anchor="ctr" wrap="square" lIns="150000" rIns="150000" tIns="150000" bIns="150000"/>
+          <a:lstStyle/>
+          <a:p>
+            <a:pPr algn="ctr">
+              <a:spcAft>
+                <a:spcPts val="300"/>
+              </a:spcAft>
+            </a:pPr>
+            <a:r>
+              <a:rPr sz="1150" b="1">
+                <a:solidFill>
+                  <a:srgbClr val="34D399"/>
+                </a:solidFill>
+                <a:latin typeface="Segoe UI"/>
+              </a:rPr>
+              <a:t>OUTPUT &amp; SAFETY DECISION LIFECYCLE FLOW</a:t>
+            </a:r>
+          </a:p>
+          <a:p>
+            <a:pPr>
+              <a:spcAft>
+                <a:spcPts val="300"/>
+              </a:spcAft>
+            </a:pPr>
+            <a:r>
+              <a:rPr sz="950" b="1">
+                <a:solidFill>
+                  <a:srgbClr val="FFFFFF"/>
+                </a:solidFill>
+                <a:latin typeface="Segoe UI"/>
+              </a:rPr>
+              <a:t>Incident Evidence ➔ Diagnosis ➔ Proposal ➔ [ Human Approval Gate ] ➔ Result</a:t>
+            </a:r>
+          </a:p>
+          <a:p>
+            <a:pPr>
+              <a:spcAft>
+                <a:spcPts val="200"/>
+              </a:spcAft>
+            </a:pPr>
+            <a:r>
+              <a:rPr sz="800">
+                <a:solidFill>
+                  <a:srgbClr val="34D399"/>
+                </a:solidFill>
+                <a:latin typeface="Consolas"/>
+              </a:rPr>
+              <a:t>  ┌──────────────┐     ┌──────────────┐     ┌──────────────────────┐
+  │  Diagnosis   │ ──► │  Remediation │ ──► │ 🛡 Human Approval Gate│
+  │  (RCA Proof) │     │   Proposal   │     │ (Mandatory for Med/Hi)│
+  └──────────────┘     └──────────────┘     └──────────┬───────────┘
+    [ APPROVED ] ──► Simulated Exec ──► Verification Checks ──► RESOLVED
+    [ REJECTED ] ──► Action Cancelled (null) ──► Stays in INVESTIGATING</a:t>
+            </a:r>
+          </a:p>
+        </p:txBody>
+      </p:sp>
+      <p:sp>
+        <p:nvSpPr>
+          <p:cNvPr id="7" name="Rounded Rectangle 6"/>
+          <p:cNvSpPr/>
+          <p:nvPr/>
+        </p:nvSpPr>
+        <p:spPr>
+          <a:xfrm>
+            <a:off x="6245352" y="3250000"/>
+            <a:ext cx="5214823" cy="3200000"/>
+          </a:xfrm>
+          <a:prstGeom prst="roundRect">
+            <a:avLst/>
+          </a:prstGeom>
+          <a:solidFill>
+            <a:srgbClr val="1E293B"/>
+          </a:solidFill>
+          <a:ln w="12700">
+            <a:solidFill>
+              <a:srgbClr val="334155"/>
+            </a:solidFill>
+          </a:ln>
+        </p:spPr>
+        <p:style>
+          <a:lnRef idx="1">
+            <a:schemeClr val="accent1"/>
+          </a:lnRef>
+          <a:fillRef idx="3">
+            <a:schemeClr val="accent1"/>
+          </a:fillRef>
+          <a:effectRef idx="2">
+            <a:schemeClr val="accent1"/>
+          </a:effectRef>
+          <a:fontRef idx="minor">
+            <a:schemeClr val="lt1"/>
+          </a:fontRef>
+        </p:style>
+        <p:txBody>
+          <a:bodyPr rtlCol="0" anchor="ctr" wrap="square" lIns="180000" rIns="180000" tIns="180000" bIns="180000"/>
+          <a:lstStyle/>
+          <a:p>
+            <a:pPr algn="ctr">
+              <a:spcAft>
+                <a:spcPts val="500"/>
+              </a:spcAft>
+            </a:pPr>
+            <a:r>
+              <a:rPr sz="1150" b="1">
+                <a:solidFill>
+                  <a:srgbClr val="FBBF24"/>
+                </a:solidFill>
+                <a:latin typeface="Segoe UI"/>
+              </a:rPr>
+              <a:t>CONCRETE DEMO OUTPUT &amp; RECOVERY LIFECYCLE</a:t>
+            </a:r>
+          </a:p>
+          <a:p>
+            <a:pPr>
+              <a:spcAft>
+                <a:spcPts val="300"/>
+              </a:spcAft>
+            </a:pPr>
+            <a:r>
+              <a:rPr sz="1000" b="1">
+                <a:solidFill>
+                  <a:srgbClr val="FFFFFF"/>
+                </a:solidFill>
+                <a:latin typeface="Segoe UI"/>
+              </a:rPr>
+              <a:t>• Diagnosis &amp; Proposal: </a:t>
+            </a:r>
+            <a:r>
+              <a:rPr sz="1000">
+                <a:solidFill>
+                  <a:srgbClr val="F1F5F9"/>
+                </a:solidFill>
+                <a:latin typeface="Segoe UI"/>
+              </a:rPr>
+              <a:t>RCA diagnosed payment-service failure. Proposed `SCALE_SERVICE` (replicas: 2), rated `MEDIUM` risk (`PENDING_APPROVAL`).</a:t>
+            </a:r>
+          </a:p>
+          <a:p>
+            <a:pPr>
+              <a:spcAft>
+                <a:spcPts val="300"/>
+              </a:spcAft>
+            </a:pPr>
+            <a:r>
+              <a:rPr sz="1000" b="1">
+                <a:solidFill>
+                  <a:srgbClr val="FFFFFF"/>
+                </a:solidFill>
+                <a:latin typeface="Segoe UI"/>
+              </a:rPr>
+              <a:t>• Approval Path (`INC-CD90E2`): </a:t>
+            </a:r>
+            <a:r>
+              <a:rPr sz="1000">
+                <a:solidFill>
+                  <a:srgbClr val="F1F5F9"/>
+                </a:solidFill>
+                <a:latin typeface="Segoe UI"/>
+              </a:rPr>
+              <a:t>Operator approved (`POST /approve`) ➔ status `APPROVED` ➔ updated simulated state (`SUCCESS`) ➔ verified healthy ➔ status `RESOLVED`.</a:t>
+            </a:r>
+          </a:p>
+          <a:p>
+            <a:pPr>
+              <a:spcAft>
+                <a:spcPts val="300"/>
+              </a:spcAft>
+            </a:pPr>
+            <a:r>
+              <a:rPr sz="1000" b="1">
+                <a:solidFill>
+                  <a:srgbClr val="FFFFFF"/>
+                </a:solidFill>
+                <a:latin typeface="Segoe UI"/>
+              </a:rPr>
+              <a:t>• Rejection Path (`INC-28EE86`): </a:t>
+            </a:r>
+            <a:r>
+              <a:rPr sz="1000">
+                <a:solidFill>
+                  <a:srgbClr val="F1F5F9"/>
+                </a:solidFill>
+                <a:latin typeface="Segoe UI"/>
+              </a:rPr>
+              <a:t>Operator rejected (`POST /reject`) ➔ status `REJECTED` ➔ execution cancelled (`null`) ➔ verification skipped ➔ remains `INVESTIGATING`.</a:t>
+            </a:r>
+          </a:p>
+          <a:p>
+            <a:pPr>
+              <a:spcAft>
+                <a:spcPts val="300"/>
+              </a:spcAft>
+            </a:pPr>
+            <a:r>
+              <a:rPr sz="1000" b="1">
+                <a:solidFill>
+                  <a:srgbClr val="FFFFFF"/>
+                </a:solidFill>
+                <a:latin typeface="Segoe UI"/>
+              </a:rPr>
+              <a:t>• Simulated vs Real Actuation: </a:t>
+            </a:r>
+            <a:r>
+              <a:rPr sz="1000">
+                <a:solidFill>
+                  <a:srgbClr val="F1F5F9"/>
+                </a:solidFill>
+                <a:latin typeface="Segoe UI"/>
+              </a:rPr>
+              <a:t>Remediation executor updated in-memory simulated state only. Live cluster deployment (`payment-service`) remained strictly at 1 replica.</a:t>
+            </a:r>
+          </a:p>
+          <a:p>
+            <a:pPr>
+              <a:spcAft>
+                <a:spcPts val="300"/>
+              </a:spcAft>
+            </a:pPr>
+            <a:r>
+              <a:rPr sz="1000" b="1">
+                <a:solidFill>
+                  <a:srgbClr val="FFFFFF"/>
+                </a:solidFill>
+                <a:latin typeface="Segoe UI"/>
+              </a:rPr>
+              <a:t>• Actual Live Recovery Truth: </a:t>
+            </a:r>
+            <a:r>
+              <a:rPr sz="1000">
+                <a:solidFill>
+                  <a:srgbClr val="F1F5F9"/>
+                </a:solidFill>
+                <a:latin typeface="Segoe UI"/>
+              </a:rPr>
+              <a:t>Live HTTP traffic recovered (10/10 OK, 1.051s latency) strictly following explicit fault cleanup (`POST /cleanup`), NOT from simulated scaling.</a:t>
+            </a:r>
+          </a:p>
+        </p:txBody>
+      </p:sp>
+    </p:spTree>
+  </p:cSld>
+  <p:clrMapOvr>
+    <a:masterClrMapping/>
+  </p:clrMapOvr>
+</p:sld>
+</file>
+
 <file path=ppt/slides/slide2.xml><?xml version="1.0" encoding="utf-8"?>
 <p:sld xmlns:a="http://schemas.openxmlformats.org/drawingml/2006/main" xmlns:p="http://schemas.openxmlformats.org/presentationml/2006/main" xmlns:r="http://schemas.openxmlformats.org/officeDocument/2006/relationships">
   <p:cSld>
@@ -7118,6 +9114,59 @@
                 <a:latin typeface="Segoe UI"/>
               </a:rPr>
               <a:t>– Enforces deterministic risk assessment before any action can proceed.</a:t>
+            </a:r>
+          </a:p>
+          <a:p>
+            <a:pPr>
+              <a:spcBef>
+                <a:spcPts val="800"/>
+              </a:spcBef>
+              <a:spcAft>
+                <a:spcPts val="200"/>
+              </a:spcAft>
+            </a:pPr>
+            <a:r>
+              <a:rPr sz="1300">
+                <a:solidFill>
+                  <a:srgbClr val="F1F5F9"/>
+                </a:solidFill>
+                <a:latin typeface="Segoe UI"/>
+              </a:rPr>
+              <a:t>• </a:t>
+            </a:r>
+            <a:r>
+              <a:rPr sz="1300" b="1">
+                <a:solidFill>
+                  <a:srgbClr val="FFFFFF"/>
+                </a:solidFill>
+                <a:latin typeface="Segoe UI"/>
+              </a:rPr>
+              <a:t>Input-to-Output Flow Summary</a:t>
+            </a:r>
+            <a:r>
+              <a:rPr sz="1300">
+                <a:solidFill>
+                  <a:srgbClr val="F1F5F9"/>
+                </a:solidFill>
+                <a:latin typeface="Segoe UI"/>
+              </a:rPr>
+              <a:t>:</a:t>
+            </a:r>
+          </a:p>
+          <a:p>
+            <a:pPr>
+              <a:spcAft>
+                <a:spcPts val="200"/>
+              </a:spcAft>
+            </a:pPr>
+            <a:r>
+              <a:rPr sz="1150">
+                <a:solidFill>
+                  <a:srgbClr val="38BDF8"/>
+                </a:solidFill>
+                <a:latin typeface="Segoe UI"/>
+              </a:rPr>
+              <a:t>• Telemetry &amp; Signals (Input) ➔ Parallel Investigation ➔ Risk Gate &amp; Verification (Output).</a:t>
             </a:r>
           </a:p>
         </p:txBody>

</xml_diff>